<commit_message>
feat: add Archon-KPMG-Pitch presentation deck
</commit_message>
<xml_diff>
--- a/deck/Archon-KPMG-Pitch.pptx
+++ b/deck/Archon-KPMG-Pitch.pptx
@@ -11421,6 +11421,36 @@
           </a:p>
         </p:txBody>
       </p:sp>
+      <p:pic>
+        <p:nvPicPr>
+          <p:cNvPr id="26" name="Picture 25">
+            <a:extLst>
+              <a:ext uri="{FF2B5EF4-FFF2-40B4-BE49-F238E27FC236}">
+                <a16:creationId xmlns:a16="http://schemas.microsoft.com/office/drawing/2014/main" id="{D2111332-5ACB-72C9-3EF0-1B835329D4B7}"/>
+              </a:ext>
+            </a:extLst>
+          </p:cNvPr>
+          <p:cNvPicPr>
+            <a:picLocks noChangeAspect="1"/>
+          </p:cNvPicPr>
+          <p:nvPr/>
+        </p:nvPicPr>
+        <p:blipFill>
+          <a:blip r:embed="rId5"/>
+          <a:stretch>
+            <a:fillRect/>
+          </a:stretch>
+        </p:blipFill>
+        <p:spPr>
+          <a:xfrm>
+            <a:off x="9144000" y="4389120"/>
+            <a:ext cx="2103120" cy="2103120"/>
+          </a:xfrm>
+          <a:prstGeom prst="rect">
+            <a:avLst/>
+          </a:prstGeom>
+        </p:spPr>
+      </p:pic>
     </p:spTree>
   </p:cSld>
   <p:clrMapOvr>

</xml_diff>